<commit_message>
Use the deck's own dash
The slides source had no em dash in it before today; I put three into
lesson 2 while rewriting the feature engineering slide, and
review_lesson.py flagged one of them on the slide itself. Replaced with
the hyphen the rest of the deck uses.
</commit_message>
<xml_diff>
--- a/Lessons/02_data_exploration_and_preparation/Slides/data_exploration_and_preparation_slides.pptx
+++ b/Lessons/02_data_exploration_and_preparation/Slides/data_exploration_and_preparation_slides.pptx
@@ -4557,7 +4557,7 @@
             </a:pPr>
             <a:r>
               <a:rPr/>
-              <a:t>The formula was on this slide as a rendered equation and came out at 23pt, the smallest in the course: the column names are long enough that no amount of trimming saves it. It is one sentence to say — total_paid is the monthly charge times the months stayed, with tenure clipped at zero first — and the three AUCs are what does the work in the room.</a:t>
+              <a:t>The formula was on this slide as a rendered equation and came out at 23pt, the smallest in the course: the column names are long enough that no amount of trimming saves it. It is one sentence to say - total_paid is the monthly charge times the months stayed, with tenure clipped at zero first - and the three AUCs are what does the work in the room.</a:t>
             </a:r>
           </a:p>
           <a:p>
@@ -14057,7 +14057,7 @@
             </a:r>
             <a:r>
               <a:rPr/>
-              <a:t> — the gain was living in the 999s.</a:t>
+              <a:t> - the gain was living in the 999s.</a:t>
             </a:r>
           </a:p>
         </p:txBody>

</xml_diff>